<commit_message>
Week 9: L17 deck, precise discussion questions and closing table
</commit_message>
<xml_diff>
--- a/Week 9/L17_Support_Copilot_Audit.pptx
+++ b/Week 9/L17_Support_Copilot_Audit.pptx
@@ -3390,7 +3390,7 @@
                 </a:solidFill>
                 <a:latin typeface="Helvetica Neue"/>
               </a:rPr>
-              <a:t>DISCUSSION</a:t>
+              <a:t>CLOSING</a:t>
             </a:r>
           </a:p>
         </p:txBody>
@@ -3419,13 +3419,13 @@
           <a:p>
             <a:pPr algn="l"/>
             <a:r>
-              <a:rPr sz="2850" b="1" i="0">
+              <a:rPr sz="2300" b="1" i="0">
                 <a:solidFill>
                   <a:srgbClr val="0F172A"/>
                 </a:solidFill>
                 <a:latin typeface="Helvetica Neue"/>
               </a:rPr>
-              <a:t>Five measurements, four of them invisible in the others</a:t>
+              <a:t>Five measurements of one pipeline, and what each one alone tells you</a:t>
             </a:r>
           </a:p>
         </p:txBody>
@@ -3460,7 +3460,7 @@
                 </a:solidFill>
                 <a:latin typeface="Helvetica Neue"/>
               </a:rPr>
-              <a:t>Where the argument lands, and what to carry into your final project.</a:t>
+              <a:t>Each row is a number from tonight's notebook and the single conclusion it supports.</a:t>
             </a:r>
           </a:p>
         </p:txBody>
@@ -3665,8 +3665,8 @@
         </p:blipFill>
         <p:spPr>
           <a:xfrm>
-            <a:off x="472287" y="2286000"/>
-            <a:ext cx="11247120" cy="3425518"/>
+            <a:off x="680220" y="2103120"/>
+            <a:ext cx="10831253" cy="4297680"/>
           </a:xfrm>
           <a:prstGeom prst="rect">
             <a:avLst/>
@@ -6067,13 +6067,13 @@
           <a:p>
             <a:pPr algn="l"/>
             <a:r>
-              <a:rPr sz="2900" b="1" i="0">
+              <a:rPr sz="2100" b="1" i="0">
                 <a:solidFill>
                   <a:srgbClr val="0F172A"/>
                 </a:solidFill>
                 <a:latin typeface="Helvetica Neue"/>
               </a:rPr>
-              <a:t>Nobody chose any of tonight's failures</a:t>
+              <a:t>Three questions: segment reporting, guardrails, and testing before release</a:t>
             </a:r>
           </a:p>
         </p:txBody>
@@ -6313,8 +6313,8 @@
         </p:blipFill>
         <p:spPr>
           <a:xfrm>
-            <a:off x="700887" y="2377440"/>
-            <a:ext cx="10789920" cy="2962390"/>
+            <a:off x="858422" y="2194560"/>
+            <a:ext cx="10474849" cy="4114800"/>
           </a:xfrm>
           <a:prstGeom prst="rect">
             <a:avLst/>

</xml_diff>

<commit_message>
Week 9: L17 deck, notebook map builds one block per click
</commit_message>
<xml_diff>
--- a/Week 9/L17_Support_Copilot_Audit.pptx
+++ b/Week 9/L17_Support_Copilot_Audit.pptx
@@ -4081,13 +4081,13 @@
           <a:p>
             <a:pPr algn="l"/>
             <a:r>
-              <a:rPr sz="2800" b="1" i="0">
+              <a:rPr sz="2250" b="1" i="0">
                 <a:solidFill>
                   <a:srgbClr val="0F172A"/>
                 </a:solidFill>
                 <a:latin typeface="Helvetica Neue"/>
               </a:rPr>
-              <a:t>Eight blocks, sixteen steps, three numbers that disagree</a:t>
+              <a:t>Eight blocks, sixteen steps: what each one measures and what it found</a:t>
             </a:r>
           </a:p>
         </p:txBody>
@@ -4313,7 +4313,7 @@
       </p:sp>
       <p:pic>
         <p:nvPicPr>
-          <p:cNvPr id="10" name="Picture 9" descr="fig_flow.png"/>
+          <p:cNvPr id="10" name="Picture 9" descr="fig_flow_L1.png"/>
           <p:cNvPicPr>
             <a:picLocks noChangeAspect="1"/>
           </p:cNvPicPr>
@@ -4327,8 +4327,176 @@
         </p:blipFill>
         <p:spPr>
           <a:xfrm>
-            <a:off x="289407" y="2079183"/>
-            <a:ext cx="11612880" cy="4116953"/>
+            <a:off x="289407" y="2053296"/>
+            <a:ext cx="11612880" cy="4168726"/>
+          </a:xfrm>
+          <a:prstGeom prst="rect">
+            <a:avLst/>
+          </a:prstGeom>
+        </p:spPr>
+      </p:pic>
+      <p:pic>
+        <p:nvPicPr>
+          <p:cNvPr id="11" name="Picture 10" descr="fig_flow_L2.png"/>
+          <p:cNvPicPr>
+            <a:picLocks noChangeAspect="1"/>
+          </p:cNvPicPr>
+          <p:nvPr/>
+        </p:nvPicPr>
+        <p:blipFill>
+          <a:blip r:embed="rId3"/>
+          <a:stretch>
+            <a:fillRect/>
+          </a:stretch>
+        </p:blipFill>
+        <p:spPr>
+          <a:xfrm>
+            <a:off x="289407" y="2053296"/>
+            <a:ext cx="11612880" cy="4168726"/>
+          </a:xfrm>
+          <a:prstGeom prst="rect">
+            <a:avLst/>
+          </a:prstGeom>
+        </p:spPr>
+      </p:pic>
+      <p:pic>
+        <p:nvPicPr>
+          <p:cNvPr id="12" name="Picture 11" descr="fig_flow_L3.png"/>
+          <p:cNvPicPr>
+            <a:picLocks noChangeAspect="1"/>
+          </p:cNvPicPr>
+          <p:nvPr/>
+        </p:nvPicPr>
+        <p:blipFill>
+          <a:blip r:embed="rId4"/>
+          <a:stretch>
+            <a:fillRect/>
+          </a:stretch>
+        </p:blipFill>
+        <p:spPr>
+          <a:xfrm>
+            <a:off x="289407" y="2053296"/>
+            <a:ext cx="11612880" cy="4168726"/>
+          </a:xfrm>
+          <a:prstGeom prst="rect">
+            <a:avLst/>
+          </a:prstGeom>
+        </p:spPr>
+      </p:pic>
+      <p:pic>
+        <p:nvPicPr>
+          <p:cNvPr id="13" name="Picture 12" descr="fig_flow_L4.png"/>
+          <p:cNvPicPr>
+            <a:picLocks noChangeAspect="1"/>
+          </p:cNvPicPr>
+          <p:nvPr/>
+        </p:nvPicPr>
+        <p:blipFill>
+          <a:blip r:embed="rId5"/>
+          <a:stretch>
+            <a:fillRect/>
+          </a:stretch>
+        </p:blipFill>
+        <p:spPr>
+          <a:xfrm>
+            <a:off x="289407" y="2053296"/>
+            <a:ext cx="11612880" cy="4168726"/>
+          </a:xfrm>
+          <a:prstGeom prst="rect">
+            <a:avLst/>
+          </a:prstGeom>
+        </p:spPr>
+      </p:pic>
+      <p:pic>
+        <p:nvPicPr>
+          <p:cNvPr id="14" name="Picture 13" descr="fig_flow_L5.png"/>
+          <p:cNvPicPr>
+            <a:picLocks noChangeAspect="1"/>
+          </p:cNvPicPr>
+          <p:nvPr/>
+        </p:nvPicPr>
+        <p:blipFill>
+          <a:blip r:embed="rId6"/>
+          <a:stretch>
+            <a:fillRect/>
+          </a:stretch>
+        </p:blipFill>
+        <p:spPr>
+          <a:xfrm>
+            <a:off x="289407" y="2053296"/>
+            <a:ext cx="11612880" cy="4168726"/>
+          </a:xfrm>
+          <a:prstGeom prst="rect">
+            <a:avLst/>
+          </a:prstGeom>
+        </p:spPr>
+      </p:pic>
+      <p:pic>
+        <p:nvPicPr>
+          <p:cNvPr id="15" name="Picture 14" descr="fig_flow_L6.png"/>
+          <p:cNvPicPr>
+            <a:picLocks noChangeAspect="1"/>
+          </p:cNvPicPr>
+          <p:nvPr/>
+        </p:nvPicPr>
+        <p:blipFill>
+          <a:blip r:embed="rId7"/>
+          <a:stretch>
+            <a:fillRect/>
+          </a:stretch>
+        </p:blipFill>
+        <p:spPr>
+          <a:xfrm>
+            <a:off x="289407" y="2053296"/>
+            <a:ext cx="11612880" cy="4168726"/>
+          </a:xfrm>
+          <a:prstGeom prst="rect">
+            <a:avLst/>
+          </a:prstGeom>
+        </p:spPr>
+      </p:pic>
+      <p:pic>
+        <p:nvPicPr>
+          <p:cNvPr id="16" name="Picture 15" descr="fig_flow_L7.png"/>
+          <p:cNvPicPr>
+            <a:picLocks noChangeAspect="1"/>
+          </p:cNvPicPr>
+          <p:nvPr/>
+        </p:nvPicPr>
+        <p:blipFill>
+          <a:blip r:embed="rId8"/>
+          <a:stretch>
+            <a:fillRect/>
+          </a:stretch>
+        </p:blipFill>
+        <p:spPr>
+          <a:xfrm>
+            <a:off x="289407" y="2053296"/>
+            <a:ext cx="11612880" cy="4168726"/>
+          </a:xfrm>
+          <a:prstGeom prst="rect">
+            <a:avLst/>
+          </a:prstGeom>
+        </p:spPr>
+      </p:pic>
+      <p:pic>
+        <p:nvPicPr>
+          <p:cNvPr id="17" name="Picture 16" descr="fig_flow_L8.png"/>
+          <p:cNvPicPr>
+            <a:picLocks noChangeAspect="1"/>
+          </p:cNvPicPr>
+          <p:nvPr/>
+        </p:nvPicPr>
+        <p:blipFill>
+          <a:blip r:embed="rId9"/>
+          <a:stretch>
+            <a:fillRect/>
+          </a:stretch>
+        </p:blipFill>
+        <p:spPr>
+          <a:xfrm>
+            <a:off x="289407" y="2053296"/>
+            <a:ext cx="11612880" cy="4168726"/>
           </a:xfrm>
           <a:prstGeom prst="rect">
             <a:avLst/>
@@ -4340,6 +4508,396 @@
   <p:clrMapOvr>
     <a:masterClrMapping/>
   </p:clrMapOvr>
+  <p:timing>
+    <p:tnLst>
+      <p:par>
+        <p:cTn id="1" dur="indefinite" restart="never" nodeType="tmRoot">
+          <p:childTnLst>
+            <p:seq concurrent="1" nextAc="seek">
+              <p:cTn id="2" dur="indefinite" nodeType="mainSeq">
+                <p:childTnLst>
+                  <p:par>
+                    <p:cTn id="3" fill="hold">
+                      <p:stCondLst>
+                        <p:cond delay="indefinite"/>
+                      </p:stCondLst>
+                      <p:childTnLst>
+                        <p:par>
+                          <p:cTn id="4" fill="hold">
+                            <p:stCondLst>
+                              <p:cond delay="0"/>
+                            </p:stCondLst>
+                            <p:childTnLst>
+                              <p:par>
+                                <p:cTn id="5" presetID="1" presetClass="entr" presetSubtype="0" fill="hold" grpId="0" nodeType="clickEffect">
+                                  <p:stCondLst>
+                                    <p:cond delay="0"/>
+                                  </p:stCondLst>
+                                  <p:childTnLst>
+                                    <p:set>
+                                      <p:cBhvr>
+                                        <p:cTn id="6" dur="1" fill="hold">
+                                          <p:stCondLst>
+                                            <p:cond delay="0"/>
+                                          </p:stCondLst>
+                                        </p:cTn>
+                                        <p:tgtEl>
+                                          <p:spTgt spid="10"/>
+                                        </p:tgtEl>
+                                        <p:attrNameLst>
+                                          <p:attrName>style.visibility</p:attrName>
+                                        </p:attrNameLst>
+                                      </p:cBhvr>
+                                      <p:to>
+                                        <p:strVal val="visible"/>
+                                      </p:to>
+                                    </p:set>
+                                  </p:childTnLst>
+                                </p:cTn>
+                              </p:par>
+                            </p:childTnLst>
+                          </p:cTn>
+                        </p:par>
+                      </p:childTnLst>
+                    </p:cTn>
+                  </p:par>
+                  <p:par>
+                    <p:cTn id="7" fill="hold">
+                      <p:stCondLst>
+                        <p:cond delay="indefinite"/>
+                      </p:stCondLst>
+                      <p:childTnLst>
+                        <p:par>
+                          <p:cTn id="8" fill="hold">
+                            <p:stCondLst>
+                              <p:cond delay="0"/>
+                            </p:stCondLst>
+                            <p:childTnLst>
+                              <p:par>
+                                <p:cTn id="9" presetID="1" presetClass="entr" presetSubtype="0" fill="hold" grpId="0" nodeType="clickEffect">
+                                  <p:stCondLst>
+                                    <p:cond delay="0"/>
+                                  </p:stCondLst>
+                                  <p:childTnLst>
+                                    <p:set>
+                                      <p:cBhvr>
+                                        <p:cTn id="10" dur="1" fill="hold">
+                                          <p:stCondLst>
+                                            <p:cond delay="0"/>
+                                          </p:stCondLst>
+                                        </p:cTn>
+                                        <p:tgtEl>
+                                          <p:spTgt spid="11"/>
+                                        </p:tgtEl>
+                                        <p:attrNameLst>
+                                          <p:attrName>style.visibility</p:attrName>
+                                        </p:attrNameLst>
+                                      </p:cBhvr>
+                                      <p:to>
+                                        <p:strVal val="visible"/>
+                                      </p:to>
+                                    </p:set>
+                                  </p:childTnLst>
+                                </p:cTn>
+                              </p:par>
+                            </p:childTnLst>
+                          </p:cTn>
+                        </p:par>
+                      </p:childTnLst>
+                    </p:cTn>
+                  </p:par>
+                  <p:par>
+                    <p:cTn id="11" fill="hold">
+                      <p:stCondLst>
+                        <p:cond delay="indefinite"/>
+                      </p:stCondLst>
+                      <p:childTnLst>
+                        <p:par>
+                          <p:cTn id="12" fill="hold">
+                            <p:stCondLst>
+                              <p:cond delay="0"/>
+                            </p:stCondLst>
+                            <p:childTnLst>
+                              <p:par>
+                                <p:cTn id="13" presetID="1" presetClass="entr" presetSubtype="0" fill="hold" grpId="0" nodeType="clickEffect">
+                                  <p:stCondLst>
+                                    <p:cond delay="0"/>
+                                  </p:stCondLst>
+                                  <p:childTnLst>
+                                    <p:set>
+                                      <p:cBhvr>
+                                        <p:cTn id="14" dur="1" fill="hold">
+                                          <p:stCondLst>
+                                            <p:cond delay="0"/>
+                                          </p:stCondLst>
+                                        </p:cTn>
+                                        <p:tgtEl>
+                                          <p:spTgt spid="12"/>
+                                        </p:tgtEl>
+                                        <p:attrNameLst>
+                                          <p:attrName>style.visibility</p:attrName>
+                                        </p:attrNameLst>
+                                      </p:cBhvr>
+                                      <p:to>
+                                        <p:strVal val="visible"/>
+                                      </p:to>
+                                    </p:set>
+                                  </p:childTnLst>
+                                </p:cTn>
+                              </p:par>
+                            </p:childTnLst>
+                          </p:cTn>
+                        </p:par>
+                      </p:childTnLst>
+                    </p:cTn>
+                  </p:par>
+                  <p:par>
+                    <p:cTn id="15" fill="hold">
+                      <p:stCondLst>
+                        <p:cond delay="indefinite"/>
+                      </p:stCondLst>
+                      <p:childTnLst>
+                        <p:par>
+                          <p:cTn id="16" fill="hold">
+                            <p:stCondLst>
+                              <p:cond delay="0"/>
+                            </p:stCondLst>
+                            <p:childTnLst>
+                              <p:par>
+                                <p:cTn id="17" presetID="1" presetClass="entr" presetSubtype="0" fill="hold" grpId="0" nodeType="clickEffect">
+                                  <p:stCondLst>
+                                    <p:cond delay="0"/>
+                                  </p:stCondLst>
+                                  <p:childTnLst>
+                                    <p:set>
+                                      <p:cBhvr>
+                                        <p:cTn id="18" dur="1" fill="hold">
+                                          <p:stCondLst>
+                                            <p:cond delay="0"/>
+                                          </p:stCondLst>
+                                        </p:cTn>
+                                        <p:tgtEl>
+                                          <p:spTgt spid="13"/>
+                                        </p:tgtEl>
+                                        <p:attrNameLst>
+                                          <p:attrName>style.visibility</p:attrName>
+                                        </p:attrNameLst>
+                                      </p:cBhvr>
+                                      <p:to>
+                                        <p:strVal val="visible"/>
+                                      </p:to>
+                                    </p:set>
+                                  </p:childTnLst>
+                                </p:cTn>
+                              </p:par>
+                            </p:childTnLst>
+                          </p:cTn>
+                        </p:par>
+                      </p:childTnLst>
+                    </p:cTn>
+                  </p:par>
+                  <p:par>
+                    <p:cTn id="19" fill="hold">
+                      <p:stCondLst>
+                        <p:cond delay="indefinite"/>
+                      </p:stCondLst>
+                      <p:childTnLst>
+                        <p:par>
+                          <p:cTn id="20" fill="hold">
+                            <p:stCondLst>
+                              <p:cond delay="0"/>
+                            </p:stCondLst>
+                            <p:childTnLst>
+                              <p:par>
+                                <p:cTn id="21" presetID="1" presetClass="entr" presetSubtype="0" fill="hold" grpId="0" nodeType="clickEffect">
+                                  <p:stCondLst>
+                                    <p:cond delay="0"/>
+                                  </p:stCondLst>
+                                  <p:childTnLst>
+                                    <p:set>
+                                      <p:cBhvr>
+                                        <p:cTn id="22" dur="1" fill="hold">
+                                          <p:stCondLst>
+                                            <p:cond delay="0"/>
+                                          </p:stCondLst>
+                                        </p:cTn>
+                                        <p:tgtEl>
+                                          <p:spTgt spid="14"/>
+                                        </p:tgtEl>
+                                        <p:attrNameLst>
+                                          <p:attrName>style.visibility</p:attrName>
+                                        </p:attrNameLst>
+                                      </p:cBhvr>
+                                      <p:to>
+                                        <p:strVal val="visible"/>
+                                      </p:to>
+                                    </p:set>
+                                  </p:childTnLst>
+                                </p:cTn>
+                              </p:par>
+                            </p:childTnLst>
+                          </p:cTn>
+                        </p:par>
+                      </p:childTnLst>
+                    </p:cTn>
+                  </p:par>
+                  <p:par>
+                    <p:cTn id="23" fill="hold">
+                      <p:stCondLst>
+                        <p:cond delay="indefinite"/>
+                      </p:stCondLst>
+                      <p:childTnLst>
+                        <p:par>
+                          <p:cTn id="24" fill="hold">
+                            <p:stCondLst>
+                              <p:cond delay="0"/>
+                            </p:stCondLst>
+                            <p:childTnLst>
+                              <p:par>
+                                <p:cTn id="25" presetID="1" presetClass="entr" presetSubtype="0" fill="hold" grpId="0" nodeType="clickEffect">
+                                  <p:stCondLst>
+                                    <p:cond delay="0"/>
+                                  </p:stCondLst>
+                                  <p:childTnLst>
+                                    <p:set>
+                                      <p:cBhvr>
+                                        <p:cTn id="26" dur="1" fill="hold">
+                                          <p:stCondLst>
+                                            <p:cond delay="0"/>
+                                          </p:stCondLst>
+                                        </p:cTn>
+                                        <p:tgtEl>
+                                          <p:spTgt spid="15"/>
+                                        </p:tgtEl>
+                                        <p:attrNameLst>
+                                          <p:attrName>style.visibility</p:attrName>
+                                        </p:attrNameLst>
+                                      </p:cBhvr>
+                                      <p:to>
+                                        <p:strVal val="visible"/>
+                                      </p:to>
+                                    </p:set>
+                                  </p:childTnLst>
+                                </p:cTn>
+                              </p:par>
+                            </p:childTnLst>
+                          </p:cTn>
+                        </p:par>
+                      </p:childTnLst>
+                    </p:cTn>
+                  </p:par>
+                  <p:par>
+                    <p:cTn id="27" fill="hold">
+                      <p:stCondLst>
+                        <p:cond delay="indefinite"/>
+                      </p:stCondLst>
+                      <p:childTnLst>
+                        <p:par>
+                          <p:cTn id="28" fill="hold">
+                            <p:stCondLst>
+                              <p:cond delay="0"/>
+                            </p:stCondLst>
+                            <p:childTnLst>
+                              <p:par>
+                                <p:cTn id="29" presetID="1" presetClass="entr" presetSubtype="0" fill="hold" grpId="0" nodeType="clickEffect">
+                                  <p:stCondLst>
+                                    <p:cond delay="0"/>
+                                  </p:stCondLst>
+                                  <p:childTnLst>
+                                    <p:set>
+                                      <p:cBhvr>
+                                        <p:cTn id="30" dur="1" fill="hold">
+                                          <p:stCondLst>
+                                            <p:cond delay="0"/>
+                                          </p:stCondLst>
+                                        </p:cTn>
+                                        <p:tgtEl>
+                                          <p:spTgt spid="16"/>
+                                        </p:tgtEl>
+                                        <p:attrNameLst>
+                                          <p:attrName>style.visibility</p:attrName>
+                                        </p:attrNameLst>
+                                      </p:cBhvr>
+                                      <p:to>
+                                        <p:strVal val="visible"/>
+                                      </p:to>
+                                    </p:set>
+                                  </p:childTnLst>
+                                </p:cTn>
+                              </p:par>
+                            </p:childTnLst>
+                          </p:cTn>
+                        </p:par>
+                      </p:childTnLst>
+                    </p:cTn>
+                  </p:par>
+                  <p:par>
+                    <p:cTn id="31" fill="hold">
+                      <p:stCondLst>
+                        <p:cond delay="indefinite"/>
+                      </p:stCondLst>
+                      <p:childTnLst>
+                        <p:par>
+                          <p:cTn id="32" fill="hold">
+                            <p:stCondLst>
+                              <p:cond delay="0"/>
+                            </p:stCondLst>
+                            <p:childTnLst>
+                              <p:par>
+                                <p:cTn id="33" presetID="1" presetClass="entr" presetSubtype="0" fill="hold" grpId="0" nodeType="clickEffect">
+                                  <p:stCondLst>
+                                    <p:cond delay="0"/>
+                                  </p:stCondLst>
+                                  <p:childTnLst>
+                                    <p:set>
+                                      <p:cBhvr>
+                                        <p:cTn id="34" dur="1" fill="hold">
+                                          <p:stCondLst>
+                                            <p:cond delay="0"/>
+                                          </p:stCondLst>
+                                        </p:cTn>
+                                        <p:tgtEl>
+                                          <p:spTgt spid="17"/>
+                                        </p:tgtEl>
+                                        <p:attrNameLst>
+                                          <p:attrName>style.visibility</p:attrName>
+                                        </p:attrNameLst>
+                                      </p:cBhvr>
+                                      <p:to>
+                                        <p:strVal val="visible"/>
+                                      </p:to>
+                                    </p:set>
+                                  </p:childTnLst>
+                                </p:cTn>
+                              </p:par>
+                            </p:childTnLst>
+                          </p:cTn>
+                        </p:par>
+                      </p:childTnLst>
+                    </p:cTn>
+                  </p:par>
+                </p:childTnLst>
+              </p:cTn>
+              <p:prevCondLst>
+                <p:cond evt="onPrev" delay="0">
+                  <p:tgtEl>
+                    <p:sldTgt/>
+                  </p:tgtEl>
+                </p:cond>
+              </p:prevCondLst>
+              <p:nextCondLst>
+                <p:cond evt="onNext" delay="0">
+                  <p:tgtEl>
+                    <p:sldTgt/>
+                  </p:tgtEl>
+                </p:cond>
+              </p:nextCondLst>
+            </p:seq>
+          </p:childTnLst>
+        </p:cTn>
+      </p:par>
+    </p:tnLst>
+  </p:timing>
 </p:sld>
 </file>
 

</xml_diff>

<commit_message>
Week 9: L17 discussion moves from competition specifics to evaluation, fairness and responsible deployment
</commit_message>
<xml_diff>
--- a/Week 9/L17_Support_Copilot_Audit.pptx
+++ b/Week 9/L17_Support_Copilot_Audit.pptx
@@ -6625,13 +6625,13 @@
           <a:p>
             <a:pPr algn="l"/>
             <a:r>
-              <a:rPr sz="2100" b="1" i="0">
+              <a:rPr sz="2350" b="1" i="0">
                 <a:solidFill>
                   <a:srgbClr val="0F172A"/>
                 </a:solidFill>
                 <a:latin typeface="Helvetica Neue"/>
               </a:rPr>
-              <a:t>Three questions: segment reporting, guardrails, and testing before release</a:t>
+              <a:t>Three questions on evaluation, fairness, and responsible deployment</a:t>
             </a:r>
           </a:p>
         </p:txBody>
@@ -6666,7 +6666,7 @@
                 </a:solidFill>
                 <a:latin typeface="Helvetica Neue"/>
               </a:rPr>
-              <a:t>Twelve minutes. Answer from a company you have actually worked at.</a:t>
+              <a:t>Twelve minutes. Answer from a company you have worked at, not from the notebook.</a:t>
             </a:r>
           </a:p>
         </p:txBody>
@@ -6871,8 +6871,8 @@
         </p:blipFill>
         <p:spPr>
           <a:xfrm>
-            <a:off x="858422" y="2194560"/>
-            <a:ext cx="10474849" cy="4114800"/>
+            <a:off x="1158930" y="2194560"/>
+            <a:ext cx="9873833" cy="4114800"/>
           </a:xfrm>
           <a:prstGeom prst="rect">
             <a:avLst/>

</xml_diff>

<commit_message>
Week 9: L17 discussion questions anchored to J&M 7.6, 11.2, 4.12 and 7.7
</commit_message>
<xml_diff>
--- a/Week 9/L17_Support_Copilot_Audit.pptx
+++ b/Week 9/L17_Support_Copilot_Audit.pptx
@@ -6666,7 +6666,7 @@
                 </a:solidFill>
                 <a:latin typeface="Helvetica Neue"/>
               </a:rPr>
-              <a:t>Twelve minutes. Answer from a company you have worked at, not from the notebook.</a:t>
+              <a:t>Twelve minutes. Each question starts from an assigned reading. Answer from a company you have worked at.</a:t>
             </a:r>
           </a:p>
         </p:txBody>
@@ -6871,8 +6871,8 @@
         </p:blipFill>
         <p:spPr>
           <a:xfrm>
-            <a:off x="1158930" y="2194560"/>
-            <a:ext cx="9873833" cy="4114800"/>
+            <a:off x="1417759" y="2194560"/>
+            <a:ext cx="9356176" cy="4114800"/>
           </a:xfrm>
           <a:prstGeom prst="rect">
             <a:avLst/>

</xml_diff>

<commit_message>
Week 9: L17 slides 3 and 4, block descriptions and what each cell computes; fix stale STEPS 9-10 / 0.049 card
</commit_message>
<xml_diff>
--- a/Week 9/L17_Support_Copilot_Audit.pptx
+++ b/Week 9/L17_Support_Copilot_Audit.pptx
@@ -5216,8 +5216,8 @@
         </p:blipFill>
         <p:spPr>
           <a:xfrm>
-            <a:off x="426567" y="2286000"/>
-            <a:ext cx="11338560" cy="2578669"/>
+            <a:off x="888121" y="2103120"/>
+            <a:ext cx="10415451" cy="4206240"/>
           </a:xfrm>
           <a:prstGeom prst="rect">
             <a:avLst/>

</xml_diff>

<commit_message>
Week 9: L17 slides 5 and 6 in plain language, retitled Libraries vs. Frameworks and LangChain vs. LangGraph
</commit_message>
<xml_diff>
--- a/Week 9/L17_Support_Copilot_Audit.pptx
+++ b/Week 9/L17_Support_Copilot_Audit.pptx
@@ -5307,7 +5307,7 @@
                 </a:solidFill>
                 <a:latin typeface="Helvetica Neue"/>
               </a:rPr>
-              <a:t>Library against framework: who invokes whom</a:t>
+              <a:t>Libraries vs. Frameworks</a:t>
             </a:r>
           </a:p>
         </p:txBody>
@@ -5342,7 +5342,7 @@
                 </a:solidFill>
                 <a:latin typeface="Helvetica Neue"/>
               </a:rPr>
-              <a:t>Reference. The mechanism, the API you write, and where each shows up in a stack trace.</a:t>
+              <a:t>Reference. Which one is in control of your program, and what that costs you either way.</a:t>
             </a:r>
           </a:p>
         </p:txBody>
@@ -5547,8 +5547,8 @@
         </p:blipFill>
         <p:spPr>
           <a:xfrm>
-            <a:off x="289407" y="2064616"/>
-            <a:ext cx="11612880" cy="4146086"/>
+            <a:off x="289407" y="2114771"/>
+            <a:ext cx="11612880" cy="4045777"/>
           </a:xfrm>
           <a:prstGeom prst="rect">
             <a:avLst/>
@@ -5638,7 +5638,7 @@
                 </a:solidFill>
                 <a:latin typeface="Helvetica Neue"/>
               </a:rPr>
-              <a:t>LangChain against LangGraph: the API contract</a:t>
+              <a:t>LangChain vs. LangGraph</a:t>
             </a:r>
           </a:p>
         </p:txBody>
@@ -5673,7 +5673,7 @@
                 </a:solidFill>
                 <a:latin typeface="Helvetica Neue"/>
               </a:rPr>
-              <a:t>Reference. Same vendor, different object, and the step count is the dividing line.</a:t>
+              <a:t>Reference. Same company, two tools. The dividing line is whether the work can go back a step.</a:t>
             </a:r>
           </a:p>
         </p:txBody>
@@ -5878,8 +5878,8 @@
         </p:blipFill>
         <p:spPr>
           <a:xfrm>
-            <a:off x="289407" y="2070084"/>
-            <a:ext cx="11612880" cy="4135150"/>
+            <a:off x="289407" y="2079584"/>
+            <a:ext cx="11612880" cy="4116150"/>
           </a:xfrm>
           <a:prstGeom prst="rect">
             <a:avLst/>

</xml_diff>

<commit_message>
Week 9: L17 discussion, question first with the reading underneath
</commit_message>
<xml_diff>
--- a/Week 9/L17_Support_Copilot_Audit.pptx
+++ b/Week 9/L17_Support_Copilot_Audit.pptx
@@ -6871,8 +6871,8 @@
         </p:blipFill>
         <p:spPr>
           <a:xfrm>
-            <a:off x="1417759" y="2194560"/>
-            <a:ext cx="9356176" cy="4114800"/>
+            <a:off x="1502491" y="2194560"/>
+            <a:ext cx="9186712" cy="4114800"/>
           </a:xfrm>
           <a:prstGeom prst="rect">
             <a:avLst/>

</xml_diff>